<commit_message>
Vision Bank deck: show all prices in USD
Co-Authored-By: Claude Opus 5.5 <noreply@anthropic.com>
Claude-Session: https://claude.ai/code/session_01SNf1Edf2HMYqmZpheYf6i6
</commit_message>
<xml_diff>
--- a/emyaa-ceo-deck/output/vision-bank/eMYAA_Saudi_Market_Plan_-_Vision_Bank.pptx
+++ b/emyaa-ceo-deck/output/vision-bank/eMYAA_Saudi_Market_Plan_-_Vision_Bank.pptx
@@ -694,7 +694,7 @@
           <a:p>
             <a:r>
               <a:rPr lang="en-US" dirty="0"/>
-              <a:t>Google Ads and LinkedIn: $30,000 approved for Sep to Dec 2026 from the reserved budget (Board update, 17 Sep 2026): Google Search Saudi $9,000, LinkedIn Affluent Saudi $9,000, Google and LinkedIn for Qatar, UAE, Kuwait, Bahrain and Oman $6,000 each. Jodel: Nadher Media proposal, 16 Sep 2026, USD 3,862.50 (SAR 14,496.25) + VAT. Outdoor: Nadher Media proposal, 23 Sep 2026, 8 weeks, SAR 168,000 + VAT (about USD 44,800 at 3.75). Jodel and outdoor are proposals and not yet approved.</a:t>
+              <a:t>Google Ads and LinkedIn: $30,000 approved for Sep to Dec 2026 from the reserved budget (Board update, 17 Sep 2026): Google Search Saudi $9,000, LinkedIn Affluent Saudi $9,000, Google and LinkedIn for Qatar, UAE, Kuwait, Bahrain and Oman $6,000 each. Jodel: Nadher Media proposal, 16 Sep 2026, USD 3,862.50 + VAT. Outdoor: Nadher Media proposal, 23 Sep 2026, 8 weeks, USD 44,800 + VAT (quoted in SAR, converted at 3.75). Jodel and outdoor are proposals and not yet approved.</a:t>
             </a:r>
             <a:endParaRPr lang="en-US" dirty="0"/>
           </a:p>
@@ -958,7 +958,7 @@
           <a:p>
             <a:r>
               <a:rPr lang="en-US" dirty="0"/>
-              <a:t>Nadher Media proposal for eMYAA, 16 Sep 2026: USD 3,862.50 (SAR 14,496.25) + VAT, 7 days, all KSA: 525,000 display and video impressions plus a 24-hour takeover poll of 2,000,000 impressions, one round of ad consulting, unlimited creatives. Cost per 1,000 impressions: about USD 1.53. Jodel KSA: 2.5M active users, 800,000 monthly unique users, average CTR 0.44%. BISB case study (Nadher Media, Oct 2025).</a:t>
+              <a:t>Nadher Media proposal for eMYAA, 16 Sep 2026: USD 3,862.50 + VAT, 7 days, all KSA: 525,000 display and video impressions plus a 24-hour takeover poll of 2,000,000 impressions, one round of ad consulting, unlimited creatives. Cost per 1,000 impressions: about USD 1.53. Jodel KSA: 2.5M active users, 800,000 monthly unique users, average CTR 0.44%. BISB case study (Nadher Media, Oct 2025).</a:t>
             </a:r>
             <a:endParaRPr lang="en-US" dirty="0"/>
           </a:p>
@@ -4753,7 +4753,7 @@
                 <a:ea typeface="Exo 2" pitchFamily="34" charset="-122"/>
                 <a:cs typeface="Exo 2" pitchFamily="34" charset="-120"/>
               </a:rPr>
-              <a:t>SAR 168,000 + VAT</a:t>
+              <a:t>USD 44,800 + VAT</a:t>
             </a:r>
             <a:endParaRPr lang="en-US" sz="1200" dirty="0"/>
           </a:p>
@@ -5388,7 +5388,7 @@
                 <a:ea typeface="Exo 2" pitchFamily="34" charset="-122"/>
                 <a:cs typeface="Exo 2" pitchFamily="34" charset="-120"/>
               </a:rPr>
-              <a:t>SAR converted at 3.75 to the USD. Outdoor and Jodel are vendor proposals, not yet approved.</a:t>
+              <a:t>All prices in USD (SAR converted at 3.75). Outdoor and Jodel are vendor proposals, not yet approved.</a:t>
             </a:r>
             <a:endParaRPr lang="en-US" sz="1000" dirty="0"/>
           </a:p>
@@ -7744,7 +7744,7 @@
                 <a:ea typeface="Exo 2" pitchFamily="34" charset="-122"/>
                 <a:cs typeface="Exo 2" pitchFamily="34" charset="-120"/>
               </a:rPr>
-              <a:t>OUTDOOR AND ELEVATOR MEDIA, RIYADH</a:t>
+              <a:t>OUTDOOR AND ELEVATOR MEDIA, SAUDI ARABIA</a:t>
             </a:r>
             <a:endParaRPr lang="en-US" sz="950" dirty="0"/>
           </a:p>
@@ -8444,7 +8444,7 @@
                 <a:ea typeface="Exo 2" pitchFamily="34" charset="-122"/>
                 <a:cs typeface="Exo 2" pitchFamily="34" charset="-120"/>
               </a:rPr>
-              <a:t>SAR 60,000</a:t>
+              <a:t>USD 16,000</a:t>
             </a:r>
             <a:endParaRPr lang="en-US" sz="1100" dirty="0"/>
           </a:p>
@@ -8636,7 +8636,7 @@
                 <a:ea typeface="Exo 2" pitchFamily="34" charset="-122"/>
                 <a:cs typeface="Exo 2" pitchFamily="34" charset="-120"/>
               </a:rPr>
-              <a:t>SAR 120,000</a:t>
+              <a:t>USD 32,000</a:t>
             </a:r>
             <a:endParaRPr lang="en-US" sz="1100" dirty="0"/>
           </a:p>
@@ -8700,7 +8700,7 @@
                 <a:ea typeface="Exo 2" pitchFamily="34" charset="-122"/>
                 <a:cs typeface="Exo 2" pitchFamily="34" charset="-120"/>
               </a:rPr>
-              <a:t>SAR 102,000</a:t>
+              <a:t>USD 27,200</a:t>
             </a:r>
             <a:endParaRPr lang="en-US" sz="1100" dirty="0"/>
           </a:p>
@@ -8892,7 +8892,7 @@
                 <a:ea typeface="Exo 2" pitchFamily="34" charset="-122"/>
                 <a:cs typeface="Exo 2" pitchFamily="34" charset="-120"/>
               </a:rPr>
-              <a:t>SAR 240,000</a:t>
+              <a:t>USD 64,000</a:t>
             </a:r>
             <a:endParaRPr lang="en-US" sz="1100" dirty="0"/>
           </a:p>
@@ -8956,7 +8956,7 @@
                 <a:ea typeface="Exo 2" pitchFamily="34" charset="-122"/>
                 <a:cs typeface="Exo 2" pitchFamily="34" charset="-120"/>
               </a:rPr>
-              <a:t>SAR 168,000</a:t>
+              <a:t>USD 44,800</a:t>
             </a:r>
             <a:endParaRPr lang="en-US" sz="1100" dirty="0"/>
           </a:p>
@@ -9148,7 +9148,7 @@
                 <a:ea typeface="Exo 2" pitchFamily="34" charset="-122"/>
                 <a:cs typeface="Exo 2" pitchFamily="34" charset="-120"/>
               </a:rPr>
-              <a:t>SAR 360,000</a:t>
+              <a:t>USD 96,000</a:t>
             </a:r>
             <a:endParaRPr lang="en-US" sz="1100" dirty="0"/>
           </a:p>
@@ -9212,7 +9212,7 @@
                 <a:ea typeface="Exo 2" pitchFamily="34" charset="-122"/>
                 <a:cs typeface="Exo 2" pitchFamily="34" charset="-120"/>
               </a:rPr>
-              <a:t>SAR 252,000</a:t>
+              <a:t>USD 67,200</a:t>
             </a:r>
             <a:endParaRPr lang="en-US" sz="1100" dirty="0"/>
           </a:p>
@@ -9404,7 +9404,7 @@
                 <a:ea typeface="Exo 2" pitchFamily="34" charset="-122"/>
                 <a:cs typeface="Exo 2" pitchFamily="34" charset="-120"/>
               </a:rPr>
-              <a:t>SAR 168,000 + VAT</a:t>
+              <a:t>USD 44,800 + VAT</a:t>
             </a:r>
             <a:endParaRPr lang="en-US" sz="2400" dirty="0"/>
           </a:p>
@@ -9443,7 +9443,7 @@
                 <a:ea typeface="Exo 2" pitchFamily="34" charset="-122"/>
                 <a:cs typeface="Exo 2" pitchFamily="34" charset="-120"/>
               </a:rPr>
-              <a:t>8 weeks, 91 screens. About USD 44,800, 30% below the original rate.</a:t>
+              <a:t>8 weeks, 91 screens, 30% below the original rate of USD 64,000.</a:t>
             </a:r>
             <a:endParaRPr lang="en-US" sz="1200" dirty="0"/>
           </a:p>
@@ -9841,7 +9841,7 @@
                 <a:ea typeface="Exo 2" pitchFamily="34" charset="-122"/>
                 <a:cs typeface="Exo 2" pitchFamily="34" charset="-120"/>
               </a:rPr>
-              <a:t>All prices + VAT. Proposal only, not yet approved.</a:t>
+              <a:t>All prices in USD + VAT. Proposal only, not yet approved.</a:t>
             </a:r>
             <a:endParaRPr lang="en-US" sz="1100" dirty="0"/>
           </a:p>
@@ -10293,7 +10293,7 @@
                 <a:ea typeface="Exo 2" pitchFamily="34" charset="-122"/>
                 <a:cs typeface="Exo 2" pitchFamily="34" charset="-120"/>
               </a:rPr>
-              <a:t>SAR 14,496.25  |  7 days  |  all of Saudi Arabia</a:t>
+              <a:t>7 days  |  all of Saudi Arabia</a:t>
             </a:r>
             <a:endParaRPr lang="en-US" sz="1200" dirty="0"/>
           </a:p>

</xml_diff>

<commit_message>
Vision Bank deck: add the Jodel logo and phone screens to the Jodel slide
Co-Authored-By: Claude Opus 5.5 <noreply@anthropic.com>
Claude-Session: https://claude.ai/code/session_01SNf1Edf2HMYqmZpheYf6i6
</commit_message>
<xml_diff>
--- a/emyaa-ceo-deck/output/vision-bank/eMYAA_Saudi_Market_Plan_-_Vision_Bank.pptx
+++ b/emyaa-ceo-deck/output/vision-bank/eMYAA_Saudi_Market_Plan_-_Vision_Bank.pptx
@@ -10141,7 +10141,7 @@
         <p:spPr>
           <a:xfrm>
             <a:off x="566928" y="1645920"/>
-            <a:ext cx="5440680" cy="2377440"/>
+            <a:ext cx="3931920" cy="2377440"/>
           </a:xfrm>
           <a:prstGeom prst="rect">
             <a:avLst/>
@@ -10166,7 +10166,7 @@
         <p:spPr>
           <a:xfrm>
             <a:off x="566928" y="1645920"/>
-            <a:ext cx="5440680" cy="41148"/>
+            <a:ext cx="3931920" cy="41148"/>
           </a:xfrm>
           <a:prstGeom prst="rect">
             <a:avLst/>
@@ -10182,16 +10182,40 @@
           </a:ln>
         </p:spPr>
       </p:sp>
-      <p:sp>
-        <p:nvSpPr>
-          <p:cNvPr id="13" name="Text 7"/>
+      <p:pic>
+        <p:nvPicPr>
+          <p:cNvPr id="13" name="Image 3" descr="/home/user/HatemIsa_202508993_IT9002_NLP_Project/emyaa-ceo-deck/working/charts/vb_jodel_icon.png">    </p:cNvPr>
+          <p:cNvPicPr>
+            <a:picLocks noChangeAspect="1"/>
+          </p:cNvPicPr>
+          <p:nvPr/>
+        </p:nvPicPr>
+        <p:blipFill>
+          <a:blip r:embed="rId4"/>
+          <a:stretch>
+            <a:fillRect/>
+          </a:stretch>
+        </p:blipFill>
+        <p:spPr>
+          <a:xfrm>
+            <a:off x="3703320" y="1810512"/>
+            <a:ext cx="594360" cy="594360"/>
+          </a:xfrm>
+          <a:prstGeom prst="rect">
+            <a:avLst/>
+          </a:prstGeom>
+        </p:spPr>
+      </p:pic>
+      <p:sp>
+        <p:nvSpPr>
+          <p:cNvPr id="14" name="Text 7"/>
           <p:cNvSpPr txBox="1"/>
           <p:nvPr/>
         </p:nvSpPr>
         <p:spPr>
           <a:xfrm>
             <a:off x="822960" y="1828800"/>
-            <a:ext cx="4572000" cy="274320"/>
+            <a:ext cx="2743200" cy="274320"/>
           </a:xfrm>
           <a:prstGeom prst="rect">
             <a:avLst/>
@@ -10223,14 +10247,14 @@
       </p:sp>
       <p:sp>
         <p:nvSpPr>
-          <p:cNvPr id="14" name="Text 8"/>
+          <p:cNvPr id="15" name="Text 8"/>
           <p:cNvSpPr txBox="1"/>
           <p:nvPr/>
         </p:nvSpPr>
         <p:spPr>
           <a:xfrm>
             <a:off x="822960" y="2148840"/>
-            <a:ext cx="4937760" cy="548640"/>
+            <a:ext cx="3566160" cy="548640"/>
           </a:xfrm>
           <a:prstGeom prst="rect">
             <a:avLst/>
@@ -10246,7 +10270,7 @@
               <a:buNone/>
             </a:pPr>
             <a:r>
-              <a:rPr lang="en-US" sz="2800" b="1" dirty="0">
+              <a:rPr lang="en-US" sz="2500" b="1" dirty="0">
                 <a:solidFill>
                   <a:srgbClr val="132257"/>
                 </a:solidFill>
@@ -10256,20 +10280,20 @@
               </a:rPr>
               <a:t>USD 3,862.50 + VAT</a:t>
             </a:r>
-            <a:endParaRPr lang="en-US" sz="2800" dirty="0"/>
-          </a:p>
-        </p:txBody>
-      </p:sp>
-      <p:sp>
-        <p:nvSpPr>
-          <p:cNvPr id="15" name="Text 9"/>
+            <a:endParaRPr lang="en-US" sz="2500" dirty="0"/>
+          </a:p>
+        </p:txBody>
+      </p:sp>
+      <p:sp>
+        <p:nvSpPr>
+          <p:cNvPr id="16" name="Text 9"/>
           <p:cNvSpPr txBox="1"/>
           <p:nvPr/>
         </p:nvSpPr>
         <p:spPr>
           <a:xfrm>
             <a:off x="822960" y="2743200"/>
-            <a:ext cx="4937760" cy="274320"/>
+            <a:ext cx="3566160" cy="274320"/>
           </a:xfrm>
           <a:prstGeom prst="rect">
             <a:avLst/>
@@ -10285,7 +10309,7 @@
               <a:buNone/>
             </a:pPr>
             <a:r>
-              <a:rPr lang="en-US" sz="1200" dirty="0">
+              <a:rPr lang="en-US" sz="1100" dirty="0">
                 <a:solidFill>
                   <a:srgbClr val="6B7590"/>
                 </a:solidFill>
@@ -10293,22 +10317,22 @@
                 <a:ea typeface="Exo 2" pitchFamily="34" charset="-122"/>
                 <a:cs typeface="Exo 2" pitchFamily="34" charset="-120"/>
               </a:rPr>
-              <a:t>7 days  |  all of Saudi Arabia</a:t>
-            </a:r>
-            <a:endParaRPr lang="en-US" sz="1200" dirty="0"/>
-          </a:p>
-        </p:txBody>
-      </p:sp>
-      <p:sp>
-        <p:nvSpPr>
-          <p:cNvPr id="16" name="Text 10"/>
+              <a:t>7 days  |  all of Saudi Arabia  |  ages 21 to 35</a:t>
+            </a:r>
+            <a:endParaRPr lang="en-US" sz="1100" dirty="0"/>
+          </a:p>
+        </p:txBody>
+      </p:sp>
+      <p:sp>
+        <p:nvSpPr>
+          <p:cNvPr id="17" name="Text 10"/>
           <p:cNvSpPr txBox="1"/>
           <p:nvPr/>
         </p:nvSpPr>
         <p:spPr>
           <a:xfrm>
             <a:off x="822960" y="3108960"/>
-            <a:ext cx="4937760" cy="731520"/>
+            <a:ext cx="3520440" cy="731520"/>
           </a:xfrm>
           <a:prstGeom prst="rect">
             <a:avLst/>
@@ -10324,7 +10348,7 @@
               <a:buNone/>
             </a:pPr>
             <a:r>
-              <a:rPr lang="en-US" sz="1200" dirty="0">
+              <a:rPr lang="en-US" sz="1150" dirty="0">
                 <a:solidFill>
                   <a:srgbClr val="1F2A44"/>
                 </a:solidFill>
@@ -10334,20 +10358,20 @@
               </a:rPr>
               <a:t>525,000 display and video impressions + 24-hour takeover poll (2,000,000 impressions)</a:t>
             </a:r>
-            <a:endParaRPr lang="en-US" sz="1200" dirty="0"/>
-          </a:p>
-        </p:txBody>
-      </p:sp>
-      <p:sp>
-        <p:nvSpPr>
-          <p:cNvPr id="17" name="Shape 11"/>
+            <a:endParaRPr lang="en-US" sz="1150" dirty="0"/>
+          </a:p>
+        </p:txBody>
+      </p:sp>
+      <p:sp>
+        <p:nvSpPr>
+          <p:cNvPr id="18" name="Shape 11"/>
           <p:cNvSpPr/>
           <p:nvPr/>
         </p:nvSpPr>
         <p:spPr>
           <a:xfrm>
             <a:off x="566928" y="4206240"/>
-            <a:ext cx="1737360" cy="1234440"/>
+            <a:ext cx="1901952" cy="1234440"/>
           </a:xfrm>
           <a:prstGeom prst="rect">
             <a:avLst/>
@@ -10365,14 +10389,14 @@
       </p:sp>
       <p:sp>
         <p:nvSpPr>
-          <p:cNvPr id="18" name="Shape 12"/>
+          <p:cNvPr id="19" name="Shape 12"/>
           <p:cNvSpPr/>
           <p:nvPr/>
         </p:nvSpPr>
         <p:spPr>
           <a:xfrm>
             <a:off x="566928" y="4206240"/>
-            <a:ext cx="1737360" cy="41148"/>
+            <a:ext cx="1901952" cy="41148"/>
           </a:xfrm>
           <a:prstGeom prst="rect">
             <a:avLst/>
@@ -10390,14 +10414,14 @@
       </p:sp>
       <p:sp>
         <p:nvSpPr>
-          <p:cNvPr id="19" name="Text 13"/>
+          <p:cNvPr id="20" name="Text 13"/>
           <p:cNvSpPr txBox="1"/>
           <p:nvPr/>
         </p:nvSpPr>
         <p:spPr>
           <a:xfrm>
             <a:off x="749808" y="4370832"/>
-            <a:ext cx="1371600" cy="502920"/>
+            <a:ext cx="1536192" cy="502920"/>
           </a:xfrm>
           <a:prstGeom prst="rect">
             <a:avLst/>
@@ -10429,14 +10453,14 @@
       </p:sp>
       <p:sp>
         <p:nvSpPr>
-          <p:cNvPr id="20" name="Text 14"/>
+          <p:cNvPr id="21" name="Text 14"/>
           <p:cNvSpPr txBox="1"/>
           <p:nvPr/>
         </p:nvSpPr>
         <p:spPr>
           <a:xfrm>
             <a:off x="749808" y="4892040"/>
-            <a:ext cx="1371600" cy="274320"/>
+            <a:ext cx="1536192" cy="274320"/>
           </a:xfrm>
           <a:prstGeom prst="rect">
             <a:avLst/>
@@ -10468,14 +10492,14 @@
       </p:sp>
       <p:sp>
         <p:nvSpPr>
-          <p:cNvPr id="21" name="Text 15"/>
+          <p:cNvPr id="22" name="Text 15"/>
           <p:cNvSpPr txBox="1"/>
           <p:nvPr/>
         </p:nvSpPr>
         <p:spPr>
           <a:xfrm>
             <a:off x="749808" y="5138928"/>
-            <a:ext cx="1371600" cy="256032"/>
+            <a:ext cx="1536192" cy="256032"/>
           </a:xfrm>
           <a:prstGeom prst="rect">
             <a:avLst/>
@@ -10507,14 +10531,14 @@
       </p:sp>
       <p:sp>
         <p:nvSpPr>
-          <p:cNvPr id="22" name="Shape 16"/>
-          <p:cNvSpPr/>
-          <p:nvPr/>
-        </p:nvSpPr>
-        <p:spPr>
-          <a:xfrm>
-            <a:off x="2423160" y="4206240"/>
-            <a:ext cx="1737360" cy="1234440"/>
+          <p:cNvPr id="23" name="Shape 16"/>
+          <p:cNvSpPr/>
+          <p:nvPr/>
+        </p:nvSpPr>
+        <p:spPr>
+          <a:xfrm>
+            <a:off x="2596896" y="4206240"/>
+            <a:ext cx="1901952" cy="1234440"/>
           </a:xfrm>
           <a:prstGeom prst="rect">
             <a:avLst/>
@@ -10532,14 +10556,14 @@
       </p:sp>
       <p:sp>
         <p:nvSpPr>
-          <p:cNvPr id="23" name="Shape 17"/>
-          <p:cNvSpPr/>
-          <p:nvPr/>
-        </p:nvSpPr>
-        <p:spPr>
-          <a:xfrm>
-            <a:off x="2423160" y="4206240"/>
-            <a:ext cx="1737360" cy="41148"/>
+          <p:cNvPr id="24" name="Shape 17"/>
+          <p:cNvSpPr/>
+          <p:nvPr/>
+        </p:nvSpPr>
+        <p:spPr>
+          <a:xfrm>
+            <a:off x="2596896" y="4206240"/>
+            <a:ext cx="1901952" cy="41148"/>
           </a:xfrm>
           <a:prstGeom prst="rect">
             <a:avLst/>
@@ -10557,14 +10581,14 @@
       </p:sp>
       <p:sp>
         <p:nvSpPr>
-          <p:cNvPr id="24" name="Text 18"/>
-          <p:cNvSpPr txBox="1"/>
-          <p:nvPr/>
-        </p:nvSpPr>
-        <p:spPr>
-          <a:xfrm>
-            <a:off x="2606040" y="4370832"/>
-            <a:ext cx="1371600" cy="502920"/>
+          <p:cNvPr id="25" name="Text 18"/>
+          <p:cNvSpPr txBox="1"/>
+          <p:nvPr/>
+        </p:nvSpPr>
+        <p:spPr>
+          <a:xfrm>
+            <a:off x="2779776" y="4370832"/>
+            <a:ext cx="1536192" cy="502920"/>
           </a:xfrm>
           <a:prstGeom prst="rect">
             <a:avLst/>
@@ -10596,14 +10620,14 @@
       </p:sp>
       <p:sp>
         <p:nvSpPr>
-          <p:cNvPr id="25" name="Text 19"/>
-          <p:cNvSpPr txBox="1"/>
-          <p:nvPr/>
-        </p:nvSpPr>
-        <p:spPr>
-          <a:xfrm>
-            <a:off x="2606040" y="4892040"/>
-            <a:ext cx="1371600" cy="274320"/>
+          <p:cNvPr id="26" name="Text 19"/>
+          <p:cNvSpPr txBox="1"/>
+          <p:nvPr/>
+        </p:nvSpPr>
+        <p:spPr>
+          <a:xfrm>
+            <a:off x="2779776" y="4892040"/>
+            <a:ext cx="1536192" cy="274320"/>
           </a:xfrm>
           <a:prstGeom prst="rect">
             <a:avLst/>
@@ -10635,14 +10659,14 @@
       </p:sp>
       <p:sp>
         <p:nvSpPr>
-          <p:cNvPr id="26" name="Text 20"/>
-          <p:cNvSpPr txBox="1"/>
-          <p:nvPr/>
-        </p:nvSpPr>
-        <p:spPr>
-          <a:xfrm>
-            <a:off x="2606040" y="5138928"/>
-            <a:ext cx="1371600" cy="256032"/>
+          <p:cNvPr id="27" name="Text 20"/>
+          <p:cNvSpPr txBox="1"/>
+          <p:nvPr/>
+        </p:nvSpPr>
+        <p:spPr>
+          <a:xfrm>
+            <a:off x="2779776" y="5138928"/>
+            <a:ext cx="1536192" cy="256032"/>
           </a:xfrm>
           <a:prstGeom prst="rect">
             <a:avLst/>
@@ -10674,14 +10698,104 @@
       </p:sp>
       <p:sp>
         <p:nvSpPr>
-          <p:cNvPr id="27" name="Shape 21"/>
-          <p:cNvSpPr/>
-          <p:nvPr/>
-        </p:nvSpPr>
-        <p:spPr>
-          <a:xfrm>
-            <a:off x="4279392" y="4206240"/>
-            <a:ext cx="1737360" cy="1234440"/>
+          <p:cNvPr id="28" name="Shape 21"/>
+          <p:cNvSpPr/>
+          <p:nvPr/>
+        </p:nvSpPr>
+        <p:spPr>
+          <a:xfrm>
+            <a:off x="4690872" y="1655064"/>
+            <a:ext cx="1798511" cy="3739896"/>
+          </a:xfrm>
+          <a:prstGeom prst="roundRect">
+            <a:avLst>
+              <a:gd name="adj" fmla="val 9152"/>
+            </a:avLst>
+          </a:prstGeom>
+          <a:solidFill>
+            <a:srgbClr val="1B1B2A"/>
+          </a:solidFill>
+          <a:ln w="12700">
+            <a:solidFill>
+              <a:srgbClr val="1B1B2A"/>
+            </a:solidFill>
+            <a:prstDash val="solid"/>
+          </a:ln>
+        </p:spPr>
+      </p:sp>
+      <p:pic>
+        <p:nvPicPr>
+          <p:cNvPr id="29" name="Image 4" descr="/home/user/HatemIsa_202508993_IT9002_NLP_Project/emyaa-ceo-deck/working/charts/vb_jodel_phone_riyadh.png">    </p:cNvPr>
+          <p:cNvPicPr>
+            <a:picLocks noChangeAspect="1"/>
+          </p:cNvPicPr>
+          <p:nvPr/>
+        </p:nvPicPr>
+        <p:blipFill>
+          <a:blip r:embed="rId5"/>
+          <a:stretch>
+            <a:fillRect/>
+          </a:stretch>
+        </p:blipFill>
+        <p:spPr>
+          <a:xfrm>
+            <a:off x="4754880" y="1719072"/>
+            <a:ext cx="1670495" cy="3611880"/>
+          </a:xfrm>
+          <a:prstGeom prst="rect">
+            <a:avLst/>
+          </a:prstGeom>
+        </p:spPr>
+      </p:pic>
+      <p:sp>
+        <p:nvSpPr>
+          <p:cNvPr id="30" name="Text 22"/>
+          <p:cNvSpPr txBox="1"/>
+          <p:nvPr/>
+        </p:nvSpPr>
+        <p:spPr>
+          <a:xfrm>
+            <a:off x="4572000" y="5422392"/>
+            <a:ext cx="2011680" cy="228600"/>
+          </a:xfrm>
+          <a:prstGeom prst="rect">
+            <a:avLst/>
+          </a:prstGeom>
+          <a:noFill/>
+          <a:ln/>
+        </p:spPr>
+        <p:txBody>
+          <a:bodyPr wrap="square" lIns="0" tIns="0" rIns="0" bIns="0" rtlCol="0" anchor="t"/>
+          <a:lstStyle/>
+          <a:p>
+            <a:pPr algn="ctr" indent="0" marL="0">
+              <a:buNone/>
+            </a:pPr>
+            <a:r>
+              <a:rPr lang="en-US" sz="900" i="1" dirty="0">
+                <a:solidFill>
+                  <a:srgbClr val="6B7590"/>
+                </a:solidFill>
+                <a:latin typeface="Exo 2" pitchFamily="34" charset="0"/>
+                <a:ea typeface="Exo 2" pitchFamily="34" charset="-122"/>
+                <a:cs typeface="Exo 2" pitchFamily="34" charset="-120"/>
+              </a:rPr>
+              <a:t>Jodel feed, Riyadh</a:t>
+            </a:r>
+            <a:endParaRPr lang="en-US" sz="900" dirty="0"/>
+          </a:p>
+        </p:txBody>
+      </p:sp>
+      <p:sp>
+        <p:nvSpPr>
+          <p:cNvPr id="31" name="Shape 23"/>
+          <p:cNvSpPr/>
+          <p:nvPr/>
+        </p:nvSpPr>
+        <p:spPr>
+          <a:xfrm>
+            <a:off x="6720840" y="1645920"/>
+            <a:ext cx="4910328" cy="3794760"/>
           </a:xfrm>
           <a:prstGeom prst="rect">
             <a:avLst/>
@@ -10699,39 +10813,39 @@
       </p:sp>
       <p:sp>
         <p:nvSpPr>
-          <p:cNvPr id="28" name="Shape 22"/>
-          <p:cNvSpPr/>
-          <p:nvPr/>
-        </p:nvSpPr>
-        <p:spPr>
-          <a:xfrm>
-            <a:off x="4279392" y="4206240"/>
-            <a:ext cx="1737360" cy="41148"/>
-          </a:xfrm>
-          <a:prstGeom prst="rect">
-            <a:avLst/>
-          </a:prstGeom>
-          <a:solidFill>
-            <a:srgbClr val="132257"/>
+          <p:cNvPr id="32" name="Shape 24"/>
+          <p:cNvSpPr/>
+          <p:nvPr/>
+        </p:nvSpPr>
+        <p:spPr>
+          <a:xfrm>
+            <a:off x="6720840" y="1645920"/>
+            <a:ext cx="4910328" cy="41148"/>
+          </a:xfrm>
+          <a:prstGeom prst="rect">
+            <a:avLst/>
+          </a:prstGeom>
+          <a:solidFill>
+            <a:srgbClr val="D4AF37"/>
           </a:solidFill>
           <a:ln w="12700">
             <a:solidFill>
-              <a:srgbClr val="132257"/>
-            </a:solidFill>
-            <a:prstDash val="solid"/>
-          </a:ln>
-        </p:spPr>
-      </p:sp>
-      <p:sp>
-        <p:nvSpPr>
-          <p:cNvPr id="29" name="Text 23"/>
-          <p:cNvSpPr txBox="1"/>
-          <p:nvPr/>
-        </p:nvSpPr>
-        <p:spPr>
-          <a:xfrm>
-            <a:off x="4462272" y="4370832"/>
-            <a:ext cx="1371600" cy="502920"/>
+              <a:srgbClr val="D4AF37"/>
+            </a:solidFill>
+            <a:prstDash val="solid"/>
+          </a:ln>
+        </p:spPr>
+      </p:sp>
+      <p:sp>
+        <p:nvSpPr>
+          <p:cNvPr id="33" name="Text 25"/>
+          <p:cNvSpPr txBox="1"/>
+          <p:nvPr/>
+        </p:nvSpPr>
+        <p:spPr>
+          <a:xfrm>
+            <a:off x="6949440" y="1828800"/>
+            <a:ext cx="3017520" cy="457200"/>
           </a:xfrm>
           <a:prstGeom prst="rect">
             <a:avLst/>
@@ -10747,7 +10861,46 @@
               <a:buNone/>
             </a:pPr>
             <a:r>
-              <a:rPr lang="en-US" sz="2600" b="1" dirty="0">
+              <a:rPr lang="en-US" sz="1000" b="1" spc="100" kern="0" dirty="0">
+                <a:solidFill>
+                  <a:srgbClr val="9A7B1F"/>
+                </a:solidFill>
+                <a:latin typeface="Exo 2" pitchFamily="34" charset="0"/>
+                <a:ea typeface="Exo 2" pitchFamily="34" charset="-122"/>
+                <a:cs typeface="Exo 2" pitchFamily="34" charset="-120"/>
+              </a:rPr>
+              <a:t>PEER RESULT: BAHRAIN ISLAMIC BANK</a:t>
+            </a:r>
+            <a:endParaRPr lang="en-US" sz="1000" dirty="0"/>
+          </a:p>
+        </p:txBody>
+      </p:sp>
+      <p:sp>
+        <p:nvSpPr>
+          <p:cNvPr id="34" name="Text 26"/>
+          <p:cNvSpPr txBox="1"/>
+          <p:nvPr/>
+        </p:nvSpPr>
+        <p:spPr>
+          <a:xfrm>
+            <a:off x="6949440" y="2286000"/>
+            <a:ext cx="2926080" cy="594360"/>
+          </a:xfrm>
+          <a:prstGeom prst="rect">
+            <a:avLst/>
+          </a:prstGeom>
+          <a:noFill/>
+          <a:ln/>
+        </p:spPr>
+        <p:txBody>
+          <a:bodyPr wrap="square" lIns="0" tIns="0" rIns="0" bIns="0" rtlCol="0" anchor="t"/>
+          <a:lstStyle/>
+          <a:p>
+            <a:pPr indent="0" marL="0">
+              <a:buNone/>
+            </a:pPr>
+            <a:r>
+              <a:rPr lang="en-US" sz="1350" b="1" dirty="0">
                 <a:solidFill>
                   <a:srgbClr val="132257"/>
                 </a:solidFill>
@@ -10755,22 +10908,22 @@
                 <a:ea typeface="Exo 2" pitchFamily="34" charset="-122"/>
                 <a:cs typeface="Exo 2" pitchFamily="34" charset="-120"/>
               </a:rPr>
-              <a:t>21 to 35</a:t>
-            </a:r>
-            <a:endParaRPr lang="en-US" sz="2600" dirty="0"/>
-          </a:p>
-        </p:txBody>
-      </p:sp>
-      <p:sp>
-        <p:nvSpPr>
-          <p:cNvPr id="30" name="Text 24"/>
-          <p:cNvSpPr txBox="1"/>
-          <p:nvPr/>
-        </p:nvSpPr>
-        <p:spPr>
-          <a:xfrm>
-            <a:off x="4462272" y="4892040"/>
-            <a:ext cx="1371600" cy="274320"/>
+              <a:t>7 days in KSA over Saudi National Day</a:t>
+            </a:r>
+            <a:endParaRPr lang="en-US" sz="1350" dirty="0"/>
+          </a:p>
+        </p:txBody>
+      </p:sp>
+      <p:sp>
+        <p:nvSpPr>
+          <p:cNvPr id="35" name="Text 27"/>
+          <p:cNvSpPr txBox="1"/>
+          <p:nvPr/>
+        </p:nvSpPr>
+        <p:spPr>
+          <a:xfrm>
+            <a:off x="6949440" y="3017520"/>
+            <a:ext cx="1463040" cy="457200"/>
           </a:xfrm>
           <a:prstGeom prst="rect">
             <a:avLst/>
@@ -10786,7 +10939,7 @@
               <a:buNone/>
             </a:pPr>
             <a:r>
-              <a:rPr lang="en-US" sz="1100" b="1" dirty="0">
+              <a:rPr lang="en-US" sz="2200" b="1" dirty="0">
                 <a:solidFill>
                   <a:srgbClr val="132257"/>
                 </a:solidFill>
@@ -10794,22 +10947,22 @@
                 <a:ea typeface="Exo 2" pitchFamily="34" charset="-122"/>
                 <a:cs typeface="Exo 2" pitchFamily="34" charset="-120"/>
               </a:rPr>
-              <a:t>audience age</a:t>
-            </a:r>
-            <a:endParaRPr lang="en-US" sz="1100" dirty="0"/>
-          </a:p>
-        </p:txBody>
-      </p:sp>
-      <p:sp>
-        <p:nvSpPr>
-          <p:cNvPr id="31" name="Text 25"/>
-          <p:cNvSpPr txBox="1"/>
-          <p:nvPr/>
-        </p:nvSpPr>
-        <p:spPr>
-          <a:xfrm>
-            <a:off x="4462272" y="5138928"/>
-            <a:ext cx="1371600" cy="256032"/>
+              <a:t>4.15M</a:t>
+            </a:r>
+            <a:endParaRPr lang="en-US" sz="2200" dirty="0"/>
+          </a:p>
+        </p:txBody>
+      </p:sp>
+      <p:sp>
+        <p:nvSpPr>
+          <p:cNvPr id="36" name="Text 28"/>
+          <p:cNvSpPr txBox="1"/>
+          <p:nvPr/>
+        </p:nvSpPr>
+        <p:spPr>
+          <a:xfrm>
+            <a:off x="6949440" y="3474720"/>
+            <a:ext cx="1463040" cy="274320"/>
           </a:xfrm>
           <a:prstGeom prst="rect">
             <a:avLst/>
@@ -10825,7 +10978,7 @@
               <a:buNone/>
             </a:pPr>
             <a:r>
-              <a:rPr lang="en-US" sz="900" dirty="0">
+              <a:rPr lang="en-US" sz="1000" dirty="0">
                 <a:solidFill>
                   <a:srgbClr val="6B7590"/>
                 </a:solidFill>
@@ -10833,455 +10986,300 @@
                 <a:ea typeface="Exo 2" pitchFamily="34" charset="-122"/>
                 <a:cs typeface="Exo 2" pitchFamily="34" charset="-120"/>
               </a:rPr>
-              <a:t>2.5M users in KSA</a:t>
-            </a:r>
-            <a:endParaRPr lang="en-US" sz="900" dirty="0"/>
-          </a:p>
-        </p:txBody>
-      </p:sp>
-      <p:sp>
-        <p:nvSpPr>
-          <p:cNvPr id="32" name="Shape 26"/>
-          <p:cNvSpPr/>
-          <p:nvPr/>
-        </p:nvSpPr>
-        <p:spPr>
-          <a:xfrm>
-            <a:off x="6355080" y="1645920"/>
-            <a:ext cx="5276088" cy="3794760"/>
-          </a:xfrm>
-          <a:prstGeom prst="rect">
-            <a:avLst/>
-          </a:prstGeom>
-          <a:solidFill>
-            <a:srgbClr val="FFFFFF"/>
-          </a:solidFill>
-          <a:ln w="9525">
-            <a:solidFill>
-              <a:srgbClr val="D9DFEA"/>
-            </a:solidFill>
-            <a:prstDash val="solid"/>
-          </a:ln>
-        </p:spPr>
-      </p:sp>
-      <p:sp>
-        <p:nvSpPr>
-          <p:cNvPr id="33" name="Shape 27"/>
-          <p:cNvSpPr/>
-          <p:nvPr/>
-        </p:nvSpPr>
-        <p:spPr>
-          <a:xfrm>
-            <a:off x="6355080" y="1645920"/>
-            <a:ext cx="5276088" cy="41148"/>
-          </a:xfrm>
-          <a:prstGeom prst="rect">
-            <a:avLst/>
-          </a:prstGeom>
-          <a:solidFill>
-            <a:srgbClr val="D4AF37"/>
+              <a:t>impressions</a:t>
+            </a:r>
+            <a:endParaRPr lang="en-US" sz="1000" dirty="0"/>
+          </a:p>
+        </p:txBody>
+      </p:sp>
+      <p:sp>
+        <p:nvSpPr>
+          <p:cNvPr id="37" name="Text 29"/>
+          <p:cNvSpPr txBox="1"/>
+          <p:nvPr/>
+        </p:nvSpPr>
+        <p:spPr>
+          <a:xfrm>
+            <a:off x="8430768" y="3017520"/>
+            <a:ext cx="1463040" cy="457200"/>
+          </a:xfrm>
+          <a:prstGeom prst="rect">
+            <a:avLst/>
+          </a:prstGeom>
+          <a:noFill/>
+          <a:ln/>
+        </p:spPr>
+        <p:txBody>
+          <a:bodyPr wrap="square" lIns="0" tIns="0" rIns="0" bIns="0" rtlCol="0" anchor="t"/>
+          <a:lstStyle/>
+          <a:p>
+            <a:pPr indent="0" marL="0">
+              <a:buNone/>
+            </a:pPr>
+            <a:r>
+              <a:rPr lang="en-US" sz="2200" b="1" dirty="0">
+                <a:solidFill>
+                  <a:srgbClr val="132257"/>
+                </a:solidFill>
+                <a:latin typeface="Exo 2" pitchFamily="34" charset="0"/>
+                <a:ea typeface="Exo 2" pitchFamily="34" charset="-122"/>
+                <a:cs typeface="Exo 2" pitchFamily="34" charset="-120"/>
+              </a:rPr>
+              <a:t>0.43%</a:t>
+            </a:r>
+            <a:endParaRPr lang="en-US" sz="2200" dirty="0"/>
+          </a:p>
+        </p:txBody>
+      </p:sp>
+      <p:sp>
+        <p:nvSpPr>
+          <p:cNvPr id="38" name="Text 30"/>
+          <p:cNvSpPr txBox="1"/>
+          <p:nvPr/>
+        </p:nvSpPr>
+        <p:spPr>
+          <a:xfrm>
+            <a:off x="8430768" y="3474720"/>
+            <a:ext cx="1463040" cy="274320"/>
+          </a:xfrm>
+          <a:prstGeom prst="rect">
+            <a:avLst/>
+          </a:prstGeom>
+          <a:noFill/>
+          <a:ln/>
+        </p:spPr>
+        <p:txBody>
+          <a:bodyPr wrap="square" lIns="0" tIns="0" rIns="0" bIns="0" rtlCol="0" anchor="t"/>
+          <a:lstStyle/>
+          <a:p>
+            <a:pPr indent="0" marL="0">
+              <a:buNone/>
+            </a:pPr>
+            <a:r>
+              <a:rPr lang="en-US" sz="1000" dirty="0">
+                <a:solidFill>
+                  <a:srgbClr val="6B7590"/>
+                </a:solidFill>
+                <a:latin typeface="Exo 2" pitchFamily="34" charset="0"/>
+                <a:ea typeface="Exo 2" pitchFamily="34" charset="-122"/>
+                <a:cs typeface="Exo 2" pitchFamily="34" charset="-120"/>
+              </a:rPr>
+              <a:t>click rate</a:t>
+            </a:r>
+            <a:endParaRPr lang="en-US" sz="1000" dirty="0"/>
+          </a:p>
+        </p:txBody>
+      </p:sp>
+      <p:sp>
+        <p:nvSpPr>
+          <p:cNvPr id="39" name="Text 31"/>
+          <p:cNvSpPr txBox="1"/>
+          <p:nvPr/>
+        </p:nvSpPr>
+        <p:spPr>
+          <a:xfrm>
+            <a:off x="6949440" y="4114800"/>
+            <a:ext cx="1463040" cy="457200"/>
+          </a:xfrm>
+          <a:prstGeom prst="rect">
+            <a:avLst/>
+          </a:prstGeom>
+          <a:noFill/>
+          <a:ln/>
+        </p:spPr>
+        <p:txBody>
+          <a:bodyPr wrap="square" lIns="0" tIns="0" rIns="0" bIns="0" rtlCol="0" anchor="t"/>
+          <a:lstStyle/>
+          <a:p>
+            <a:pPr indent="0" marL="0">
+              <a:buNone/>
+            </a:pPr>
+            <a:r>
+              <a:rPr lang="en-US" sz="2200" b="1" dirty="0">
+                <a:solidFill>
+                  <a:srgbClr val="132257"/>
+                </a:solidFill>
+                <a:latin typeface="Exo 2" pitchFamily="34" charset="0"/>
+                <a:ea typeface="Exo 2" pitchFamily="34" charset="-122"/>
+                <a:cs typeface="Exo 2" pitchFamily="34" charset="-120"/>
+              </a:rPr>
+              <a:t>700+</a:t>
+            </a:r>
+            <a:endParaRPr lang="en-US" sz="2200" dirty="0"/>
+          </a:p>
+        </p:txBody>
+      </p:sp>
+      <p:sp>
+        <p:nvSpPr>
+          <p:cNvPr id="40" name="Text 32"/>
+          <p:cNvSpPr txBox="1"/>
+          <p:nvPr/>
+        </p:nvSpPr>
+        <p:spPr>
+          <a:xfrm>
+            <a:off x="6949440" y="4572000"/>
+            <a:ext cx="1463040" cy="274320"/>
+          </a:xfrm>
+          <a:prstGeom prst="rect">
+            <a:avLst/>
+          </a:prstGeom>
+          <a:noFill/>
+          <a:ln/>
+        </p:spPr>
+        <p:txBody>
+          <a:bodyPr wrap="square" lIns="0" tIns="0" rIns="0" bIns="0" rtlCol="0" anchor="t"/>
+          <a:lstStyle/>
+          <a:p>
+            <a:pPr indent="0" marL="0">
+              <a:buNone/>
+            </a:pPr>
+            <a:r>
+              <a:rPr lang="en-US" sz="1000" dirty="0">
+                <a:solidFill>
+                  <a:srgbClr val="6B7590"/>
+                </a:solidFill>
+                <a:latin typeface="Exo 2" pitchFamily="34" charset="0"/>
+                <a:ea typeface="Exo 2" pitchFamily="34" charset="-122"/>
+                <a:cs typeface="Exo 2" pitchFamily="34" charset="-120"/>
+              </a:rPr>
+              <a:t>app downloads</a:t>
+            </a:r>
+            <a:endParaRPr lang="en-US" sz="1000" dirty="0"/>
+          </a:p>
+        </p:txBody>
+      </p:sp>
+      <p:sp>
+        <p:nvSpPr>
+          <p:cNvPr id="41" name="Text 33"/>
+          <p:cNvSpPr txBox="1"/>
+          <p:nvPr/>
+        </p:nvSpPr>
+        <p:spPr>
+          <a:xfrm>
+            <a:off x="8430768" y="4114800"/>
+            <a:ext cx="1463040" cy="457200"/>
+          </a:xfrm>
+          <a:prstGeom prst="rect">
+            <a:avLst/>
+          </a:prstGeom>
+          <a:noFill/>
+          <a:ln/>
+        </p:spPr>
+        <p:txBody>
+          <a:bodyPr wrap="square" lIns="0" tIns="0" rIns="0" bIns="0" rtlCol="0" anchor="t"/>
+          <a:lstStyle/>
+          <a:p>
+            <a:pPr indent="0" marL="0">
+              <a:buNone/>
+            </a:pPr>
+            <a:r>
+              <a:rPr lang="en-US" sz="2200" b="1" dirty="0">
+                <a:solidFill>
+                  <a:srgbClr val="132257"/>
+                </a:solidFill>
+                <a:latin typeface="Exo 2" pitchFamily="34" charset="0"/>
+                <a:ea typeface="Exo 2" pitchFamily="34" charset="-122"/>
+                <a:cs typeface="Exo 2" pitchFamily="34" charset="-120"/>
+              </a:rPr>
+              <a:t>240</a:t>
+            </a:r>
+            <a:endParaRPr lang="en-US" sz="2200" dirty="0"/>
+          </a:p>
+        </p:txBody>
+      </p:sp>
+      <p:sp>
+        <p:nvSpPr>
+          <p:cNvPr id="42" name="Text 34"/>
+          <p:cNvSpPr txBox="1"/>
+          <p:nvPr/>
+        </p:nvSpPr>
+        <p:spPr>
+          <a:xfrm>
+            <a:off x="8430768" y="4572000"/>
+            <a:ext cx="1463040" cy="274320"/>
+          </a:xfrm>
+          <a:prstGeom prst="rect">
+            <a:avLst/>
+          </a:prstGeom>
+          <a:noFill/>
+          <a:ln/>
+        </p:spPr>
+        <p:txBody>
+          <a:bodyPr wrap="square" lIns="0" tIns="0" rIns="0" bIns="0" rtlCol="0" anchor="t"/>
+          <a:lstStyle/>
+          <a:p>
+            <a:pPr indent="0" marL="0">
+              <a:buNone/>
+            </a:pPr>
+            <a:r>
+              <a:rPr lang="en-US" sz="1000" dirty="0">
+                <a:solidFill>
+                  <a:srgbClr val="6B7590"/>
+                </a:solidFill>
+                <a:latin typeface="Exo 2" pitchFamily="34" charset="0"/>
+                <a:ea typeface="Exo 2" pitchFamily="34" charset="-122"/>
+                <a:cs typeface="Exo 2" pitchFamily="34" charset="-120"/>
+              </a:rPr>
+              <a:t>accounts opened</a:t>
+            </a:r>
+            <a:endParaRPr lang="en-US" sz="1000" dirty="0"/>
+          </a:p>
+        </p:txBody>
+      </p:sp>
+      <p:sp>
+        <p:nvSpPr>
+          <p:cNvPr id="43" name="Shape 35"/>
+          <p:cNvSpPr/>
+          <p:nvPr/>
+        </p:nvSpPr>
+        <p:spPr>
+          <a:xfrm>
+            <a:off x="9948672" y="1810512"/>
+            <a:ext cx="1631101" cy="3374136"/>
+          </a:xfrm>
+          <a:prstGeom prst="roundRect">
+            <a:avLst>
+              <a:gd name="adj" fmla="val 10091"/>
+            </a:avLst>
+          </a:prstGeom>
+          <a:solidFill>
+            <a:srgbClr val="1B1B2A"/>
           </a:solidFill>
           <a:ln w="12700">
             <a:solidFill>
-              <a:srgbClr val="D4AF37"/>
-            </a:solidFill>
-            <a:prstDash val="solid"/>
-          </a:ln>
-        </p:spPr>
-      </p:sp>
-      <p:sp>
-        <p:nvSpPr>
-          <p:cNvPr id="34" name="Text 28"/>
-          <p:cNvSpPr txBox="1"/>
-          <p:nvPr/>
-        </p:nvSpPr>
-        <p:spPr>
-          <a:xfrm>
-            <a:off x="6629400" y="1828800"/>
-            <a:ext cx="4846320" cy="274320"/>
-          </a:xfrm>
-          <a:prstGeom prst="rect">
-            <a:avLst/>
-          </a:prstGeom>
-          <a:noFill/>
-          <a:ln/>
-        </p:spPr>
-        <p:txBody>
-          <a:bodyPr wrap="square" lIns="0" tIns="0" rIns="0" bIns="0" rtlCol="0" anchor="t"/>
-          <a:lstStyle/>
-          <a:p>
-            <a:pPr indent="0" marL="0">
-              <a:buNone/>
-            </a:pPr>
-            <a:r>
-              <a:rPr lang="en-US" sz="1000" b="1" spc="100" kern="0" dirty="0">
-                <a:solidFill>
-                  <a:srgbClr val="9A7B1F"/>
-                </a:solidFill>
-                <a:latin typeface="Exo 2" pitchFamily="34" charset="0"/>
-                <a:ea typeface="Exo 2" pitchFamily="34" charset="-122"/>
-                <a:cs typeface="Exo 2" pitchFamily="34" charset="-120"/>
-              </a:rPr>
-              <a:t>PEER RESULT: BAHRAIN ISLAMIC BANK IN KSA</a:t>
-            </a:r>
-            <a:endParaRPr lang="en-US" sz="1000" dirty="0"/>
-          </a:p>
-        </p:txBody>
-      </p:sp>
-      <p:sp>
-        <p:nvSpPr>
-          <p:cNvPr id="35" name="Text 29"/>
-          <p:cNvSpPr txBox="1"/>
-          <p:nvPr/>
-        </p:nvSpPr>
-        <p:spPr>
-          <a:xfrm>
-            <a:off x="6629400" y="2121408"/>
-            <a:ext cx="4754880" cy="365760"/>
-          </a:xfrm>
-          <a:prstGeom prst="rect">
-            <a:avLst/>
-          </a:prstGeom>
-          <a:noFill/>
-          <a:ln/>
-        </p:spPr>
-        <p:txBody>
-          <a:bodyPr wrap="square" lIns="0" tIns="0" rIns="0" bIns="0" rtlCol="0" anchor="t"/>
-          <a:lstStyle/>
-          <a:p>
-            <a:pPr indent="0" marL="0">
-              <a:buNone/>
-            </a:pPr>
-            <a:r>
-              <a:rPr lang="en-US" sz="1500" b="1" dirty="0">
-                <a:solidFill>
-                  <a:srgbClr val="132257"/>
-                </a:solidFill>
-                <a:latin typeface="Exo 2" pitchFamily="34" charset="0"/>
-                <a:ea typeface="Exo 2" pitchFamily="34" charset="-122"/>
-                <a:cs typeface="Exo 2" pitchFamily="34" charset="-120"/>
-              </a:rPr>
-              <a:t>7 days over Saudi National Day</a:t>
-            </a:r>
-            <a:endParaRPr lang="en-US" sz="1500" dirty="0"/>
-          </a:p>
-        </p:txBody>
-      </p:sp>
-      <p:sp>
-        <p:nvSpPr>
-          <p:cNvPr id="36" name="Text 30"/>
-          <p:cNvSpPr txBox="1"/>
-          <p:nvPr/>
-        </p:nvSpPr>
-        <p:spPr>
-          <a:xfrm>
-            <a:off x="6629400" y="2697480"/>
-            <a:ext cx="2286000" cy="548640"/>
-          </a:xfrm>
-          <a:prstGeom prst="rect">
-            <a:avLst/>
-          </a:prstGeom>
-          <a:noFill/>
-          <a:ln/>
-        </p:spPr>
-        <p:txBody>
-          <a:bodyPr wrap="square" lIns="0" tIns="0" rIns="0" bIns="0" rtlCol="0" anchor="t"/>
-          <a:lstStyle/>
-          <a:p>
-            <a:pPr indent="0" marL="0">
-              <a:buNone/>
-            </a:pPr>
-            <a:r>
-              <a:rPr lang="en-US" sz="2800" b="1" dirty="0">
-                <a:solidFill>
-                  <a:srgbClr val="132257"/>
-                </a:solidFill>
-                <a:latin typeface="Exo 2" pitchFamily="34" charset="0"/>
-                <a:ea typeface="Exo 2" pitchFamily="34" charset="-122"/>
-                <a:cs typeface="Exo 2" pitchFamily="34" charset="-120"/>
-              </a:rPr>
-              <a:t>4.15M</a:t>
-            </a:r>
-            <a:endParaRPr lang="en-US" sz="2800" dirty="0"/>
-          </a:p>
-        </p:txBody>
-      </p:sp>
-      <p:sp>
-        <p:nvSpPr>
-          <p:cNvPr id="37" name="Text 31"/>
-          <p:cNvSpPr txBox="1"/>
-          <p:nvPr/>
-        </p:nvSpPr>
-        <p:spPr>
-          <a:xfrm>
-            <a:off x="6629400" y="3246120"/>
-            <a:ext cx="2286000" cy="274320"/>
-          </a:xfrm>
-          <a:prstGeom prst="rect">
-            <a:avLst/>
-          </a:prstGeom>
-          <a:noFill/>
-          <a:ln/>
-        </p:spPr>
-        <p:txBody>
-          <a:bodyPr wrap="square" lIns="0" tIns="0" rIns="0" bIns="0" rtlCol="0" anchor="t"/>
-          <a:lstStyle/>
-          <a:p>
-            <a:pPr indent="0" marL="0">
-              <a:buNone/>
-            </a:pPr>
-            <a:r>
-              <a:rPr lang="en-US" sz="1100" dirty="0">
-                <a:solidFill>
-                  <a:srgbClr val="6B7590"/>
-                </a:solidFill>
-                <a:latin typeface="Exo 2" pitchFamily="34" charset="0"/>
-                <a:ea typeface="Exo 2" pitchFamily="34" charset="-122"/>
-                <a:cs typeface="Exo 2" pitchFamily="34" charset="-120"/>
-              </a:rPr>
-              <a:t>impressions</a:t>
-            </a:r>
-            <a:endParaRPr lang="en-US" sz="1100" dirty="0"/>
-          </a:p>
-        </p:txBody>
-      </p:sp>
-      <p:sp>
-        <p:nvSpPr>
-          <p:cNvPr id="38" name="Text 32"/>
-          <p:cNvSpPr txBox="1"/>
-          <p:nvPr/>
-        </p:nvSpPr>
-        <p:spPr>
-          <a:xfrm>
-            <a:off x="9098280" y="2697480"/>
-            <a:ext cx="2286000" cy="548640"/>
-          </a:xfrm>
-          <a:prstGeom prst="rect">
-            <a:avLst/>
-          </a:prstGeom>
-          <a:noFill/>
-          <a:ln/>
-        </p:spPr>
-        <p:txBody>
-          <a:bodyPr wrap="square" lIns="0" tIns="0" rIns="0" bIns="0" rtlCol="0" anchor="t"/>
-          <a:lstStyle/>
-          <a:p>
-            <a:pPr indent="0" marL="0">
-              <a:buNone/>
-            </a:pPr>
-            <a:r>
-              <a:rPr lang="en-US" sz="2800" b="1" dirty="0">
-                <a:solidFill>
-                  <a:srgbClr val="132257"/>
-                </a:solidFill>
-                <a:latin typeface="Exo 2" pitchFamily="34" charset="0"/>
-                <a:ea typeface="Exo 2" pitchFamily="34" charset="-122"/>
-                <a:cs typeface="Exo 2" pitchFamily="34" charset="-120"/>
-              </a:rPr>
-              <a:t>0.43%</a:t>
-            </a:r>
-            <a:endParaRPr lang="en-US" sz="2800" dirty="0"/>
-          </a:p>
-        </p:txBody>
-      </p:sp>
-      <p:sp>
-        <p:nvSpPr>
-          <p:cNvPr id="39" name="Text 33"/>
-          <p:cNvSpPr txBox="1"/>
-          <p:nvPr/>
-        </p:nvSpPr>
-        <p:spPr>
-          <a:xfrm>
-            <a:off x="9098280" y="3246120"/>
-            <a:ext cx="2286000" cy="274320"/>
-          </a:xfrm>
-          <a:prstGeom prst="rect">
-            <a:avLst/>
-          </a:prstGeom>
-          <a:noFill/>
-          <a:ln/>
-        </p:spPr>
-        <p:txBody>
-          <a:bodyPr wrap="square" lIns="0" tIns="0" rIns="0" bIns="0" rtlCol="0" anchor="t"/>
-          <a:lstStyle/>
-          <a:p>
-            <a:pPr indent="0" marL="0">
-              <a:buNone/>
-            </a:pPr>
-            <a:r>
-              <a:rPr lang="en-US" sz="1100" dirty="0">
-                <a:solidFill>
-                  <a:srgbClr val="6B7590"/>
-                </a:solidFill>
-                <a:latin typeface="Exo 2" pitchFamily="34" charset="0"/>
-                <a:ea typeface="Exo 2" pitchFamily="34" charset="-122"/>
-                <a:cs typeface="Exo 2" pitchFamily="34" charset="-120"/>
-              </a:rPr>
-              <a:t>click rate</a:t>
-            </a:r>
-            <a:endParaRPr lang="en-US" sz="1100" dirty="0"/>
-          </a:p>
-        </p:txBody>
-      </p:sp>
-      <p:sp>
-        <p:nvSpPr>
-          <p:cNvPr id="40" name="Text 34"/>
-          <p:cNvSpPr txBox="1"/>
-          <p:nvPr/>
-        </p:nvSpPr>
-        <p:spPr>
-          <a:xfrm>
-            <a:off x="6629400" y="3931920"/>
-            <a:ext cx="2286000" cy="548640"/>
-          </a:xfrm>
-          <a:prstGeom prst="rect">
-            <a:avLst/>
-          </a:prstGeom>
-          <a:noFill/>
-          <a:ln/>
-        </p:spPr>
-        <p:txBody>
-          <a:bodyPr wrap="square" lIns="0" tIns="0" rIns="0" bIns="0" rtlCol="0" anchor="t"/>
-          <a:lstStyle/>
-          <a:p>
-            <a:pPr indent="0" marL="0">
-              <a:buNone/>
-            </a:pPr>
-            <a:r>
-              <a:rPr lang="en-US" sz="2800" b="1" dirty="0">
-                <a:solidFill>
-                  <a:srgbClr val="132257"/>
-                </a:solidFill>
-                <a:latin typeface="Exo 2" pitchFamily="34" charset="0"/>
-                <a:ea typeface="Exo 2" pitchFamily="34" charset="-122"/>
-                <a:cs typeface="Exo 2" pitchFamily="34" charset="-120"/>
-              </a:rPr>
-              <a:t>700+</a:t>
-            </a:r>
-            <a:endParaRPr lang="en-US" sz="2800" dirty="0"/>
-          </a:p>
-        </p:txBody>
-      </p:sp>
-      <p:sp>
-        <p:nvSpPr>
-          <p:cNvPr id="41" name="Text 35"/>
-          <p:cNvSpPr txBox="1"/>
-          <p:nvPr/>
-        </p:nvSpPr>
-        <p:spPr>
-          <a:xfrm>
-            <a:off x="6629400" y="4480560"/>
-            <a:ext cx="2286000" cy="274320"/>
-          </a:xfrm>
-          <a:prstGeom prst="rect">
-            <a:avLst/>
-          </a:prstGeom>
-          <a:noFill/>
-          <a:ln/>
-        </p:spPr>
-        <p:txBody>
-          <a:bodyPr wrap="square" lIns="0" tIns="0" rIns="0" bIns="0" rtlCol="0" anchor="t"/>
-          <a:lstStyle/>
-          <a:p>
-            <a:pPr indent="0" marL="0">
-              <a:buNone/>
-            </a:pPr>
-            <a:r>
-              <a:rPr lang="en-US" sz="1100" dirty="0">
-                <a:solidFill>
-                  <a:srgbClr val="6B7590"/>
-                </a:solidFill>
-                <a:latin typeface="Exo 2" pitchFamily="34" charset="0"/>
-                <a:ea typeface="Exo 2" pitchFamily="34" charset="-122"/>
-                <a:cs typeface="Exo 2" pitchFamily="34" charset="-120"/>
-              </a:rPr>
-              <a:t>app downloads</a:t>
-            </a:r>
-            <a:endParaRPr lang="en-US" sz="1100" dirty="0"/>
-          </a:p>
-        </p:txBody>
-      </p:sp>
-      <p:sp>
-        <p:nvSpPr>
-          <p:cNvPr id="42" name="Text 36"/>
-          <p:cNvSpPr txBox="1"/>
-          <p:nvPr/>
-        </p:nvSpPr>
-        <p:spPr>
-          <a:xfrm>
-            <a:off x="9098280" y="3931920"/>
-            <a:ext cx="2286000" cy="548640"/>
-          </a:xfrm>
-          <a:prstGeom prst="rect">
-            <a:avLst/>
-          </a:prstGeom>
-          <a:noFill/>
-          <a:ln/>
-        </p:spPr>
-        <p:txBody>
-          <a:bodyPr wrap="square" lIns="0" tIns="0" rIns="0" bIns="0" rtlCol="0" anchor="t"/>
-          <a:lstStyle/>
-          <a:p>
-            <a:pPr indent="0" marL="0">
-              <a:buNone/>
-            </a:pPr>
-            <a:r>
-              <a:rPr lang="en-US" sz="2800" b="1" dirty="0">
-                <a:solidFill>
-                  <a:srgbClr val="132257"/>
-                </a:solidFill>
-                <a:latin typeface="Exo 2" pitchFamily="34" charset="0"/>
-                <a:ea typeface="Exo 2" pitchFamily="34" charset="-122"/>
-                <a:cs typeface="Exo 2" pitchFamily="34" charset="-120"/>
-              </a:rPr>
-              <a:t>240</a:t>
-            </a:r>
-            <a:endParaRPr lang="en-US" sz="2800" dirty="0"/>
-          </a:p>
-        </p:txBody>
-      </p:sp>
-      <p:sp>
-        <p:nvSpPr>
-          <p:cNvPr id="43" name="Text 37"/>
-          <p:cNvSpPr txBox="1"/>
-          <p:nvPr/>
-        </p:nvSpPr>
-        <p:spPr>
-          <a:xfrm>
-            <a:off x="9098280" y="4480560"/>
-            <a:ext cx="2286000" cy="274320"/>
-          </a:xfrm>
-          <a:prstGeom prst="rect">
-            <a:avLst/>
-          </a:prstGeom>
-          <a:noFill/>
-          <a:ln/>
-        </p:spPr>
-        <p:txBody>
-          <a:bodyPr wrap="square" lIns="0" tIns="0" rIns="0" bIns="0" rtlCol="0" anchor="t"/>
-          <a:lstStyle/>
-          <a:p>
-            <a:pPr indent="0" marL="0">
-              <a:buNone/>
-            </a:pPr>
-            <a:r>
-              <a:rPr lang="en-US" sz="1100" dirty="0">
-                <a:solidFill>
-                  <a:srgbClr val="6B7590"/>
-                </a:solidFill>
-                <a:latin typeface="Exo 2" pitchFamily="34" charset="0"/>
-                <a:ea typeface="Exo 2" pitchFamily="34" charset="-122"/>
-                <a:cs typeface="Exo 2" pitchFamily="34" charset="-120"/>
-              </a:rPr>
-              <a:t>accounts opened</a:t>
-            </a:r>
-            <a:endParaRPr lang="en-US" sz="1100" dirty="0"/>
-          </a:p>
-        </p:txBody>
-      </p:sp>
-      <p:sp>
-        <p:nvSpPr>
-          <p:cNvPr id="44" name="Shape 38"/>
+              <a:srgbClr val="1B1B2A"/>
+            </a:solidFill>
+            <a:prstDash val="solid"/>
+          </a:ln>
+        </p:spPr>
+      </p:sp>
+      <p:pic>
+        <p:nvPicPr>
+          <p:cNvPr id="44" name="Image 5" descr="/home/user/HatemIsa_202508993_IT9002_NLP_Project/emyaa-ceo-deck/working/charts/vb_jodel_phone_bisb.png">    </p:cNvPr>
+          <p:cNvPicPr>
+            <a:picLocks noChangeAspect="1"/>
+          </p:cNvPicPr>
+          <p:nvPr/>
+        </p:nvPicPr>
+        <p:blipFill>
+          <a:blip r:embed="rId6"/>
+          <a:stretch>
+            <a:fillRect/>
+          </a:stretch>
+        </p:blipFill>
+        <p:spPr>
+          <a:xfrm>
+            <a:off x="10012680" y="1874520"/>
+            <a:ext cx="1503085" cy="3246120"/>
+          </a:xfrm>
+          <a:prstGeom prst="rect">
+            <a:avLst/>
+          </a:prstGeom>
+        </p:spPr>
+      </p:pic>
+      <p:sp>
+        <p:nvSpPr>
+          <p:cNvPr id="45" name="Shape 36"/>
           <p:cNvSpPr/>
           <p:nvPr/>
         </p:nvSpPr>
@@ -11306,7 +11304,7 @@
       </p:sp>
       <p:sp>
         <p:nvSpPr>
-          <p:cNvPr id="45" name="Text 39"/>
+          <p:cNvPr id="46" name="Text 37"/>
           <p:cNvSpPr txBox="1"/>
           <p:nvPr/>
         </p:nvSpPr>

</xml_diff>